<commit_message>
Update PowerPoint for song #234 in FUBC - Українські
</commit_message>
<xml_diff>
--- a/fubc-ua/234-Долиною плачу (Пісні Спасенних №233).pptx
+++ b/fubc-ua/234-Долиною плачу (Пісні Спасенних №233).pptx
@@ -1558,7 +1558,7 @@
         </p:nvSpPr>
         <p:spPr>
           <a:xfrm>
-            <a:off x="2502179" y="2755392"/>
+            <a:off x="2601239" y="2755392"/>
             <a:ext cx="0" cy="2971800"/>
           </a:xfrm>
           <a:prstGeom prst="line">
@@ -1581,7 +1581,7 @@
         </p:nvSpPr>
         <p:spPr>
           <a:xfrm>
-            <a:off x="9695917" y="2755392"/>
+            <a:off x="9596857" y="2755392"/>
             <a:ext cx="0" cy="2971800"/>
           </a:xfrm>
           <a:prstGeom prst="line">
@@ -1604,8 +1604,8 @@
         </p:nvSpPr>
         <p:spPr>
           <a:xfrm>
-            <a:off x="9827997" y="4010152"/>
-            <a:ext cx="792480" cy="462280"/>
+            <a:off x="9695917" y="3921252"/>
+            <a:ext cx="1097280" cy="640080"/>
           </a:xfrm>
           <a:prstGeom prst="rect">
             <a:avLst/>
@@ -1621,9 +1621,9 @@
               <a:buNone/>
             </a:pPr>
             <a:r>
-              <a:rPr lang="en-US" sz="2600" b="1" dirty="0">
-                <a:solidFill>
-                  <a:srgbClr val="8A8A8A"/>
+              <a:rPr lang="en-US" sz="3600" b="1" dirty="0">
+                <a:solidFill>
+                  <a:srgbClr val="BBBBBB"/>
                 </a:solidFill>
                 <a:latin typeface="Arial" pitchFamily="34" charset="0"/>
                 <a:ea typeface="Arial" pitchFamily="34" charset="-122"/>
@@ -1631,7 +1631,7 @@
               </a:rPr>
               <a:t>×2</a:t>
             </a:r>
-            <a:endParaRPr lang="en-US" sz="2600" dirty="0"/>
+            <a:endParaRPr lang="en-US" sz="3600" dirty="0"/>
           </a:p>
         </p:txBody>
       </p:sp>
@@ -1837,7 +1837,7 @@
         </p:nvSpPr>
         <p:spPr>
           <a:xfrm>
-            <a:off x="2220297" y="3156966"/>
+            <a:off x="2317452" y="3156966"/>
             <a:ext cx="0" cy="2914650"/>
           </a:xfrm>
           <a:prstGeom prst="line">
@@ -1860,7 +1860,7 @@
         </p:nvSpPr>
         <p:spPr>
           <a:xfrm>
-            <a:off x="9977799" y="3156966"/>
+            <a:off x="9880644" y="3156966"/>
             <a:ext cx="0" cy="2914650"/>
           </a:xfrm>
           <a:prstGeom prst="line">
@@ -1883,8 +1883,8 @@
         </p:nvSpPr>
         <p:spPr>
           <a:xfrm>
-            <a:off x="10107339" y="4383151"/>
-            <a:ext cx="792480" cy="462280"/>
+            <a:off x="9977799" y="4294251"/>
+            <a:ext cx="1097280" cy="640080"/>
           </a:xfrm>
           <a:prstGeom prst="rect">
             <a:avLst/>
@@ -1900,9 +1900,9 @@
               <a:buNone/>
             </a:pPr>
             <a:r>
-              <a:rPr lang="en-US" sz="2600" b="1" dirty="0">
-                <a:solidFill>
-                  <a:srgbClr val="8A8A8A"/>
+              <a:rPr lang="en-US" sz="3600" b="1" dirty="0">
+                <a:solidFill>
+                  <a:srgbClr val="BBBBBB"/>
                 </a:solidFill>
                 <a:latin typeface="Arial" pitchFamily="34" charset="0"/>
                 <a:ea typeface="Arial" pitchFamily="34" charset="-122"/>
@@ -1910,7 +1910,7 @@
               </a:rPr>
               <a:t>×2</a:t>
             </a:r>
-            <a:endParaRPr lang="en-US" sz="2600" dirty="0"/>
+            <a:endParaRPr lang="en-US" sz="3600" dirty="0"/>
           </a:p>
         </p:txBody>
       </p:sp>
@@ -2116,7 +2116,7 @@
         </p:nvSpPr>
         <p:spPr>
           <a:xfrm>
-            <a:off x="1919046" y="3151632"/>
+            <a:off x="2018106" y="3151632"/>
             <a:ext cx="0" cy="2971800"/>
           </a:xfrm>
           <a:prstGeom prst="line">
@@ -2139,7 +2139,7 @@
         </p:nvSpPr>
         <p:spPr>
           <a:xfrm>
-            <a:off x="10279050" y="3151632"/>
+            <a:off x="10179990" y="3151632"/>
             <a:ext cx="0" cy="2971800"/>
           </a:xfrm>
           <a:prstGeom prst="line">
@@ -2162,8 +2162,8 @@
         </p:nvSpPr>
         <p:spPr>
           <a:xfrm>
-            <a:off x="10411130" y="4406392"/>
-            <a:ext cx="792480" cy="462280"/>
+            <a:off x="10279050" y="4317492"/>
+            <a:ext cx="1097280" cy="640080"/>
           </a:xfrm>
           <a:prstGeom prst="rect">
             <a:avLst/>
@@ -2179,9 +2179,9 @@
               <a:buNone/>
             </a:pPr>
             <a:r>
-              <a:rPr lang="en-US" sz="2600" b="1" dirty="0">
-                <a:solidFill>
-                  <a:srgbClr val="8A8A8A"/>
+              <a:rPr lang="en-US" sz="3600" b="1" dirty="0">
+                <a:solidFill>
+                  <a:srgbClr val="BBBBBB"/>
                 </a:solidFill>
                 <a:latin typeface="Arial" pitchFamily="34" charset="0"/>
                 <a:ea typeface="Arial" pitchFamily="34" charset="-122"/>
@@ -2189,7 +2189,7 @@
               </a:rPr>
               <a:t>×2</a:t>
             </a:r>
-            <a:endParaRPr lang="en-US" sz="2600" dirty="0"/>
+            <a:endParaRPr lang="en-US" sz="3600" dirty="0"/>
           </a:p>
         </p:txBody>
       </p:sp>
@@ -2395,7 +2395,7 @@
         </p:nvSpPr>
         <p:spPr>
           <a:xfrm>
-            <a:off x="2915590" y="3151632"/>
+            <a:off x="3014650" y="3151632"/>
             <a:ext cx="0" cy="2971800"/>
           </a:xfrm>
           <a:prstGeom prst="line">
@@ -2418,7 +2418,7 @@
         </p:nvSpPr>
         <p:spPr>
           <a:xfrm>
-            <a:off x="9282506" y="3151632"/>
+            <a:off x="9183446" y="3151632"/>
             <a:ext cx="0" cy="2971800"/>
           </a:xfrm>
           <a:prstGeom prst="line">
@@ -2441,8 +2441,8 @@
         </p:nvSpPr>
         <p:spPr>
           <a:xfrm>
-            <a:off x="9414586" y="4406392"/>
-            <a:ext cx="792480" cy="462280"/>
+            <a:off x="9282506" y="4317492"/>
+            <a:ext cx="1097280" cy="640080"/>
           </a:xfrm>
           <a:prstGeom prst="rect">
             <a:avLst/>
@@ -2458,9 +2458,9 @@
               <a:buNone/>
             </a:pPr>
             <a:r>
-              <a:rPr lang="en-US" sz="2600" b="1" dirty="0">
-                <a:solidFill>
-                  <a:srgbClr val="8A8A8A"/>
+              <a:rPr lang="en-US" sz="3600" b="1" dirty="0">
+                <a:solidFill>
+                  <a:srgbClr val="BBBBBB"/>
                 </a:solidFill>
                 <a:latin typeface="Arial" pitchFamily="34" charset="0"/>
                 <a:ea typeface="Arial" pitchFamily="34" charset="-122"/>
@@ -2468,7 +2468,7 @@
               </a:rPr>
               <a:t>×2</a:t>
             </a:r>
-            <a:endParaRPr lang="en-US" sz="2600" dirty="0"/>
+            <a:endParaRPr lang="en-US" sz="3600" dirty="0"/>
           </a:p>
         </p:txBody>
       </p:sp>

</xml_diff>